<commit_message>
Add Milestone 4 evaluation outputs and rebuild presentation with figures.
</commit_message>
<xml_diff>
--- a/reports/presentation.pptx
+++ b/reports/presentation.pptx
@@ -3231,7 +3231,7 @@
         <p:spPr>
           <a:xfrm>
             <a:off x="548640" y="1097280"/>
-            <a:ext cx="10972800" cy="5029200"/>
+            <a:ext cx="5669280" cy="5029200"/>
           </a:xfrm>
           <a:prstGeom prst="rect">
             <a:avLst/>
@@ -3293,6 +3293,30 @@
           </a:p>
         </p:txBody>
       </p:sp>
+      <p:pic>
+        <p:nvPicPr>
+          <p:cNvPr id="4" name="Picture 3" descr="cross_generator_accuracy.png"/>
+          <p:cNvPicPr>
+            <a:picLocks noChangeAspect="1"/>
+          </p:cNvPicPr>
+          <p:nvPr/>
+        </p:nvPicPr>
+        <p:blipFill>
+          <a:blip r:embed="rId2"/>
+          <a:stretch>
+            <a:fillRect/>
+          </a:stretch>
+        </p:blipFill>
+        <p:spPr>
+          <a:xfrm>
+            <a:off x="6400800" y="1188720"/>
+            <a:ext cx="5029200" cy="3143250"/>
+          </a:xfrm>
+          <a:prstGeom prst="rect">
+            <a:avLst/>
+          </a:prstGeom>
+        </p:spPr>
+      </p:pic>
     </p:spTree>
   </p:cSld>
   <p:clrMapOvr>
@@ -3354,7 +3378,7 @@
         <p:spPr>
           <a:xfrm>
             <a:off x="548640" y="1097280"/>
-            <a:ext cx="10972800" cy="5029200"/>
+            <a:ext cx="5669280" cy="5029200"/>
           </a:xfrm>
           <a:prstGeom prst="rect">
             <a:avLst/>
@@ -3416,6 +3440,30 @@
           </a:p>
         </p:txBody>
       </p:sp>
+      <p:pic>
+        <p:nvPicPr>
+          <p:cNvPr id="4" name="Picture 3" descr="degradation_waterfall.png"/>
+          <p:cNvPicPr>
+            <a:picLocks noChangeAspect="1"/>
+          </p:cNvPicPr>
+          <p:nvPr/>
+        </p:nvPicPr>
+        <p:blipFill>
+          <a:blip r:embed="rId2"/>
+          <a:stretch>
+            <a:fillRect/>
+          </a:stretch>
+        </p:blipFill>
+        <p:spPr>
+          <a:xfrm>
+            <a:off x="6400800" y="1188720"/>
+            <a:ext cx="5029200" cy="3143250"/>
+          </a:xfrm>
+          <a:prstGeom prst="rect">
+            <a:avLst/>
+          </a:prstGeom>
+        </p:spPr>
+      </p:pic>
     </p:spTree>
   </p:cSld>
   <p:clrMapOvr>
@@ -3477,7 +3525,7 @@
         <p:spPr>
           <a:xfrm>
             <a:off x="548640" y="1097280"/>
-            <a:ext cx="10972800" cy="5029200"/>
+            <a:ext cx="5669280" cy="5029200"/>
           </a:xfrm>
           <a:prstGeom prst="rect">
             <a:avLst/>
@@ -3555,6 +3603,30 @@
           </a:p>
         </p:txBody>
       </p:sp>
+      <p:pic>
+        <p:nvPicPr>
+          <p:cNvPr id="4" name="Picture 3" descr="feature_space_tsne.png"/>
+          <p:cNvPicPr>
+            <a:picLocks noChangeAspect="1"/>
+          </p:cNvPicPr>
+          <p:nvPr/>
+        </p:nvPicPr>
+        <p:blipFill>
+          <a:blip r:embed="rId2"/>
+          <a:stretch>
+            <a:fillRect/>
+          </a:stretch>
+        </p:blipFill>
+        <p:spPr>
+          <a:xfrm>
+            <a:off x="6400800" y="1188720"/>
+            <a:ext cx="5029200" cy="4023360"/>
+          </a:xfrm>
+          <a:prstGeom prst="rect">
+            <a:avLst/>
+          </a:prstGeom>
+        </p:spPr>
+      </p:pic>
     </p:spTree>
   </p:cSld>
   <p:clrMapOvr>

</xml_diff>

<commit_message>
Fold resolution-control results into final report and presentation.
</commit_message>
<xml_diff>
--- a/reports/presentation.pptx
+++ b/reports/presentation.pptx
@@ -3403,7 +3403,7 @@
                 </a:solidFill>
                 <a:latin typeface="Calibri"/>
               </a:rPr>
-              <a:t>• Universal chronological gap: REFUTED for 4/5 families.</a:t>
+              <a:t>• Naive protocol: transfer looks strong except GPT-4o.</a:t>
             </a:r>
           </a:p>
           <a:p>
@@ -3419,7 +3419,7 @@
                 </a:solidFill>
                 <a:latin typeface="Calibri"/>
               </a:rPr>
-              <a:t>• Autoregressive = hard: PARTLY REFUTED (Janus-Pro easy).</a:t>
+              <a:t>• Control: 93% of high-res reals called FAKE → confound.</a:t>
             </a:r>
           </a:p>
           <a:p>
@@ -3435,7 +3435,23 @@
                 </a:solidFill>
                 <a:latin typeface="Calibri"/>
               </a:rPr>
-              <a:t>• GPT-4o-specific feature-absence gap: SUPPORTED.</a:t>
+              <a:t>• After matching: broad gap (fake detection ~35–62%).</a:t>
+            </a:r>
+          </a:p>
+          <a:p>
+            <a:pPr>
+              <a:spcAft>
+                <a:spcPts val="800"/>
+              </a:spcAft>
+            </a:pPr>
+            <a:r>
+              <a:rPr sz="1600" b="0">
+                <a:solidFill>
+                  <a:srgbClr val="1E1E1E"/>
+                </a:solidFill>
+                <a:latin typeface="Calibri"/>
+              </a:rPr>
+              <a:t>• GPT-4o feature-absence remains a secondary native-protocol finding.</a:t>
             </a:r>
           </a:p>
         </p:txBody>
@@ -3674,7 +3690,7 @@
                 </a:solidFill>
                 <a:latin typeface="Calibri"/>
               </a:rPr>
-              <a:t>Resolution Control</a:t>
+              <a:t>Resolution Control — Confound Confirmed</a:t>
             </a:r>
           </a:p>
         </p:txBody>
@@ -3688,7 +3704,7 @@
         <p:spPr>
           <a:xfrm>
             <a:off x="548640" y="1097280"/>
-            <a:ext cx="10972800" cy="5029200"/>
+            <a:ext cx="5669280" cy="5029200"/>
           </a:xfrm>
           <a:prstGeom prst="rect">
             <a:avLst/>
@@ -3713,7 +3729,7 @@
                 </a:solidFill>
                 <a:latin typeface="Calibri"/>
               </a:rPr>
-              <a:t>• Do high-res reals get called FAKE under the same pipeline?</a:t>
+              <a:t>• A CIFAKE REAL: 1.7% predicted FAKE.</a:t>
             </a:r>
           </a:p>
           <a:p>
@@ -3729,7 +3745,7 @@
                 </a:solidFill>
                 <a:latin typeface="Calibri"/>
               </a:rPr>
-              <a:t>• A: CIFAKE real · B: hi-res real · C: hi-res→32 · D: fakes→32.</a:t>
+              <a:t>• B Hi-res REAL: 93.0% predicted FAKE — not generator detection.</a:t>
             </a:r>
           </a:p>
           <a:p>
@@ -3745,7 +3761,7 @@
                 </a:solidFill>
                 <a:latin typeface="Calibri"/>
               </a:rPr>
-              <a:t>• If B ≫ A → confound; if B ≈ A → transfer is genuine.</a:t>
+              <a:t>• C Same photos →32×32: FAKE-rate falls to 37.3%.</a:t>
             </a:r>
           </a:p>
           <a:p>
@@ -3761,11 +3777,51 @@
                 </a:solidFill>
                 <a:latin typeface="Calibri"/>
               </a:rPr>
-              <a:t>• Run notebook 07; figure embeds when present.</a:t>
-            </a:r>
-          </a:p>
-        </p:txBody>
-      </p:sp>
+              <a:t>• Matched fakes collapse: Midjourney 94%→35%, StyleGAN 94%→38%.</a:t>
+            </a:r>
+          </a:p>
+          <a:p>
+            <a:pPr>
+              <a:spcAft>
+                <a:spcPts val="800"/>
+              </a:spcAft>
+            </a:pPr>
+            <a:r>
+              <a:rPr sz="1600" b="0">
+                <a:solidFill>
+                  <a:srgbClr val="1E1E1E"/>
+                </a:solidFill>
+                <a:latin typeface="Calibri"/>
+              </a:rPr>
+              <a:t>• Experiment 3 transfer was largely resolution-driven.</a:t>
+            </a:r>
+          </a:p>
+        </p:txBody>
+      </p:sp>
+      <p:pic>
+        <p:nvPicPr>
+          <p:cNvPr id="4" name="Picture 3" descr="fake_rate_by_condition.png"/>
+          <p:cNvPicPr>
+            <a:picLocks noChangeAspect="1"/>
+          </p:cNvPicPr>
+          <p:nvPr/>
+        </p:nvPicPr>
+        <p:blipFill>
+          <a:blip r:embed="rId2"/>
+          <a:stretch>
+            <a:fillRect/>
+          </a:stretch>
+        </p:blipFill>
+        <p:spPr>
+          <a:xfrm>
+            <a:off x="6400800" y="1188720"/>
+            <a:ext cx="5029200" cy="2794000"/>
+          </a:xfrm>
+          <a:prstGeom prst="rect">
+            <a:avLst/>
+          </a:prstGeom>
+        </p:spPr>
+      </p:pic>
     </p:spTree>
   </p:cSld>
   <p:clrMapOvr>
@@ -4114,7 +4170,7 @@
                 </a:solidFill>
                 <a:latin typeface="Calibri"/>
               </a:rPr>
-              <a:t>• Strong CIFAKE detector (96.96%, AUC 0.9971).</a:t>
+              <a:t>• Strong CIFAKE detector in-distribution (96.96%, AUC 0.9971).</a:t>
             </a:r>
           </a:p>
           <a:p>
@@ -4130,7 +4186,7 @@
                 </a:solidFill>
                 <a:latin typeface="Calibri"/>
               </a:rPr>
-              <a:t>• Broad transfer — except GPT-4o (feature absence).</a:t>
+              <a:t>• Naive cross-generator transfer was resolution-confounded.</a:t>
             </a:r>
           </a:p>
           <a:p>
@@ -4146,7 +4202,7 @@
                 </a:solidFill>
                 <a:latin typeface="Calibri"/>
               </a:rPr>
-              <a:t>• Calibration does not transfer under shift.</a:t>
+              <a:t>• Matched-resolution eval reveals a broad generalisation gap.</a:t>
             </a:r>
           </a:p>
           <a:p>
@@ -4162,7 +4218,23 @@
                 </a:solidFill>
                 <a:latin typeface="Calibri"/>
               </a:rPr>
-              <a:t>• Resolution controls are essential for this evaluation protocol.</a:t>
+              <a:t>• GPT-4o: feature absence under native protocol (FFT / t-SNE / Grad-CAM).</a:t>
+            </a:r>
+          </a:p>
+          <a:p>
+            <a:pPr>
+              <a:spcAft>
+                <a:spcPts val="800"/>
+              </a:spcAft>
+            </a:pPr>
+            <a:r>
+              <a:rPr sz="1600" b="0">
+                <a:solidFill>
+                  <a:srgbClr val="1E1E1E"/>
+                </a:solidFill>
+                <a:latin typeface="Calibri"/>
+              </a:rPr>
+              <a:t>• Low-res benchmarks need matched-resolution real controls.</a:t>
             </a:r>
           </a:p>
           <a:p>

</xml_diff>